<commit_message>
Add data source citations to pitch deck slides 2 and 3
Co-authored-by: ueidesantos <4821809+ueidesantos@users.noreply.github.com>
</commit_message>
<xml_diff>
--- a/pitch-deck/JBF_Capital_Pitch_Deck.pptx
+++ b/pitch-deck/JBF_Capital_Pitch_Deck.pptx
@@ -3456,8 +3456,8 @@
         </p:nvSpPr>
         <p:spPr>
           <a:xfrm>
-            <a:off x="457200" y="6400800"/>
-            <a:ext cx="1371600" cy="274320"/>
+            <a:off x="640080" y="5943600"/>
+            <a:ext cx="7863840" cy="365760"/>
           </a:xfrm>
           <a:prstGeom prst="rect">
             <a:avLst/>
@@ -3470,15 +3470,15 @@
           </a:bodyPr>
           <a:lstStyle/>
           <a:p>
-            <a:pPr>
-              <a:defRPr sz="1000" b="1">
-                <a:solidFill>
-                  <a:srgbClr val="64748B"/>
-                </a:solidFill>
-              </a:defRPr>
-            </a:pPr>
-            <a:r>
-              <a:t>JBF Capital</a:t>
+            <a:pPr algn="l">
+              <a:defRPr sz="900">
+                <a:solidFill>
+                  <a:srgbClr val="94A3B8"/>
+                </a:solidFill>
+              </a:defRPr>
+            </a:pPr>
+            <a:r>
+              <a:t>Fontes: Banco Central do Brasil (2024), FEBRABAN (2024), Fitch Ratings (2024), Instituto Locomotiva (2024)</a:t>
             </a:r>
           </a:p>
         </p:txBody>
@@ -3491,8 +3491,8 @@
         </p:nvSpPr>
         <p:spPr>
           <a:xfrm>
-            <a:off x="2286000" y="6400800"/>
-            <a:ext cx="4572000" cy="274320"/>
+            <a:off x="457200" y="6400800"/>
+            <a:ext cx="1371600" cy="274320"/>
           </a:xfrm>
           <a:prstGeom prst="rect">
             <a:avLst/>
@@ -3505,6 +3505,41 @@
           </a:bodyPr>
           <a:lstStyle/>
           <a:p>
+            <a:pPr>
+              <a:defRPr sz="1000" b="1">
+                <a:solidFill>
+                  <a:srgbClr val="64748B"/>
+                </a:solidFill>
+              </a:defRPr>
+            </a:pPr>
+            <a:r>
+              <a:t>JBF Capital</a:t>
+            </a:r>
+          </a:p>
+        </p:txBody>
+      </p:sp>
+      <p:sp>
+        <p:nvSpPr>
+          <p:cNvPr id="7" name="TextBox 6"/>
+          <p:cNvSpPr txBox="1"/>
+          <p:nvPr/>
+        </p:nvSpPr>
+        <p:spPr>
+          <a:xfrm>
+            <a:off x="2286000" y="6400800"/>
+            <a:ext cx="4572000" cy="274320"/>
+          </a:xfrm>
+          <a:prstGeom prst="rect">
+            <a:avLst/>
+          </a:prstGeom>
+          <a:noFill/>
+        </p:spPr>
+        <p:txBody>
+          <a:bodyPr wrap="none">
+            <a:spAutoFit/>
+          </a:bodyPr>
+          <a:lstStyle/>
+          <a:p>
             <a:pPr algn="ctr">
               <a:defRPr sz="1000">
                 <a:solidFill>
@@ -3520,7 +3555,7 @@
       </p:sp>
       <p:sp>
         <p:nvSpPr>
-          <p:cNvPr id="7" name="TextBox 6"/>
+          <p:cNvPr id="8" name="TextBox 7"/>
           <p:cNvSpPr txBox="1"/>
           <p:nvPr/>
         </p:nvSpPr>
@@ -4085,8 +4120,8 @@
         </p:nvSpPr>
         <p:spPr>
           <a:xfrm>
-            <a:off x="457200" y="6400800"/>
-            <a:ext cx="1371600" cy="274320"/>
+            <a:off x="1371600" y="5760720"/>
+            <a:ext cx="6400800" cy="274320"/>
           </a:xfrm>
           <a:prstGeom prst="rect">
             <a:avLst/>
@@ -4099,15 +4134,15 @@
           </a:bodyPr>
           <a:lstStyle/>
           <a:p>
-            <a:pPr>
-              <a:defRPr sz="1000" b="1">
-                <a:solidFill>
-                  <a:srgbClr val="64748B"/>
-                </a:solidFill>
-              </a:defRPr>
-            </a:pPr>
-            <a:r>
-              <a:t>JBF Capital</a:t>
+            <a:pPr algn="ctr">
+              <a:defRPr sz="900">
+                <a:solidFill>
+                  <a:srgbClr val="94A3B8"/>
+                </a:solidFill>
+              </a:defRPr>
+            </a:pPr>
+            <a:r>
+              <a:t>Fonte: Serasa Experian - Pesquisa de Comportamento de Crédito do Brasileiro, 2025</a:t>
             </a:r>
           </a:p>
         </p:txBody>
@@ -4120,8 +4155,8 @@
         </p:nvSpPr>
         <p:spPr>
           <a:xfrm>
-            <a:off x="2286000" y="6400800"/>
-            <a:ext cx="4572000" cy="274320"/>
+            <a:off x="457200" y="6400800"/>
+            <a:ext cx="1371600" cy="274320"/>
           </a:xfrm>
           <a:prstGeom prst="rect">
             <a:avLst/>
@@ -4134,6 +4169,41 @@
           </a:bodyPr>
           <a:lstStyle/>
           <a:p>
+            <a:pPr>
+              <a:defRPr sz="1000" b="1">
+                <a:solidFill>
+                  <a:srgbClr val="64748B"/>
+                </a:solidFill>
+              </a:defRPr>
+            </a:pPr>
+            <a:r>
+              <a:t>JBF Capital</a:t>
+            </a:r>
+          </a:p>
+        </p:txBody>
+      </p:sp>
+      <p:sp>
+        <p:nvSpPr>
+          <p:cNvPr id="11" name="TextBox 10"/>
+          <p:cNvSpPr txBox="1"/>
+          <p:nvPr/>
+        </p:nvSpPr>
+        <p:spPr>
+          <a:xfrm>
+            <a:off x="2286000" y="6400800"/>
+            <a:ext cx="4572000" cy="274320"/>
+          </a:xfrm>
+          <a:prstGeom prst="rect">
+            <a:avLst/>
+          </a:prstGeom>
+          <a:noFill/>
+        </p:spPr>
+        <p:txBody>
+          <a:bodyPr wrap="none">
+            <a:spAutoFit/>
+          </a:bodyPr>
+          <a:lstStyle/>
+          <a:p>
             <a:pPr algn="ctr">
               <a:defRPr sz="1000">
                 <a:solidFill>
@@ -4149,7 +4219,7 @@
       </p:sp>
       <p:sp>
         <p:nvSpPr>
-          <p:cNvPr id="11" name="TextBox 10"/>
+          <p:cNvPr id="12" name="TextBox 11"/>
           <p:cNvSpPr txBox="1"/>
           <p:nvPr/>
         </p:nvSpPr>

</xml_diff>

<commit_message>
Recreate presentation from HTML slides in teste_apresentacao
Co-authored-by: ueidesantos <4821809+ueidesantos@users.noreply.github.com>
</commit_message>
<xml_diff>
--- a/pitch-deck/JBF_Capital_Pitch_Deck.pptx
+++ b/pitch-deck/JBF_Capital_Pitch_Deck.pptx
@@ -3098,7 +3098,7 @@
       <p:grpSpPr/>
       <p:pic>
         <p:nvPicPr>
-          <p:cNvPr id="2" name="Picture 1" descr="Screenshot_1.png"/>
+          <p:cNvPr id="2" name="Picture 1" descr="Slide_1.png"/>
           <p:cNvPicPr>
             <a:picLocks noChangeAspect="1"/>
           </p:cNvPicPr>
@@ -3112,49 +3112,14 @@
         </p:blipFill>
         <p:spPr>
           <a:xfrm>
-            <a:off x="228600" y="130302"/>
-            <a:ext cx="8686800" cy="4882896"/>
+            <a:off x="0" y="0"/>
+            <a:ext cx="9144000" cy="5143500"/>
           </a:xfrm>
           <a:prstGeom prst="rect">
             <a:avLst/>
           </a:prstGeom>
         </p:spPr>
       </p:pic>
-      <p:sp>
-        <p:nvSpPr>
-          <p:cNvPr id="3" name="TextBox 2"/>
-          <p:cNvSpPr txBox="1"/>
-          <p:nvPr/>
-        </p:nvSpPr>
-        <p:spPr>
-          <a:xfrm>
-            <a:off x="8229600" y="4754880"/>
-            <a:ext cx="731520" cy="274320"/>
-          </a:xfrm>
-          <a:prstGeom prst="rect">
-            <a:avLst/>
-          </a:prstGeom>
-          <a:noFill/>
-        </p:spPr>
-        <p:txBody>
-          <a:bodyPr wrap="none">
-            <a:spAutoFit/>
-          </a:bodyPr>
-          <a:lstStyle/>
-          <a:p>
-            <a:pPr algn="ctr">
-              <a:defRPr sz="1000">
-                <a:solidFill>
-                  <a:srgbClr val="64748B"/>
-                </a:solidFill>
-              </a:defRPr>
-            </a:pPr>
-            <a:r>
-              <a:t>1/9</a:t>
-            </a:r>
-          </a:p>
-        </p:txBody>
-      </p:sp>
     </p:spTree>
   </p:cSld>
   <p:clrMapOvr>
@@ -3175,7 +3140,7 @@
       <p:grpSpPr/>
       <p:pic>
         <p:nvPicPr>
-          <p:cNvPr id="2" name="Picture 1" descr="Screenshot_2.png"/>
+          <p:cNvPr id="2" name="Picture 1" descr="Slide_2.png"/>
           <p:cNvPicPr>
             <a:picLocks noChangeAspect="1"/>
           </p:cNvPicPr>
@@ -3189,49 +3154,14 @@
         </p:blipFill>
         <p:spPr>
           <a:xfrm>
-            <a:off x="228600" y="130302"/>
-            <a:ext cx="8686800" cy="4882896"/>
+            <a:off x="0" y="0"/>
+            <a:ext cx="9144000" cy="5143500"/>
           </a:xfrm>
           <a:prstGeom prst="rect">
             <a:avLst/>
           </a:prstGeom>
         </p:spPr>
       </p:pic>
-      <p:sp>
-        <p:nvSpPr>
-          <p:cNvPr id="3" name="TextBox 2"/>
-          <p:cNvSpPr txBox="1"/>
-          <p:nvPr/>
-        </p:nvSpPr>
-        <p:spPr>
-          <a:xfrm>
-            <a:off x="8229600" y="4754880"/>
-            <a:ext cx="731520" cy="274320"/>
-          </a:xfrm>
-          <a:prstGeom prst="rect">
-            <a:avLst/>
-          </a:prstGeom>
-          <a:noFill/>
-        </p:spPr>
-        <p:txBody>
-          <a:bodyPr wrap="none">
-            <a:spAutoFit/>
-          </a:bodyPr>
-          <a:lstStyle/>
-          <a:p>
-            <a:pPr algn="ctr">
-              <a:defRPr sz="1000">
-                <a:solidFill>
-                  <a:srgbClr val="64748B"/>
-                </a:solidFill>
-              </a:defRPr>
-            </a:pPr>
-            <a:r>
-              <a:t>2/9</a:t>
-            </a:r>
-          </a:p>
-        </p:txBody>
-      </p:sp>
     </p:spTree>
   </p:cSld>
   <p:clrMapOvr>
@@ -3252,7 +3182,7 @@
       <p:grpSpPr/>
       <p:pic>
         <p:nvPicPr>
-          <p:cNvPr id="2" name="Picture 1" descr="Screenshot_3.png"/>
+          <p:cNvPr id="2" name="Picture 1" descr="Slide_3.png"/>
           <p:cNvPicPr>
             <a:picLocks noChangeAspect="1"/>
           </p:cNvPicPr>
@@ -3266,49 +3196,14 @@
         </p:blipFill>
         <p:spPr>
           <a:xfrm>
-            <a:off x="228600" y="130302"/>
-            <a:ext cx="8686800" cy="4882896"/>
+            <a:off x="0" y="0"/>
+            <a:ext cx="9144000" cy="5143500"/>
           </a:xfrm>
           <a:prstGeom prst="rect">
             <a:avLst/>
           </a:prstGeom>
         </p:spPr>
       </p:pic>
-      <p:sp>
-        <p:nvSpPr>
-          <p:cNvPr id="3" name="TextBox 2"/>
-          <p:cNvSpPr txBox="1"/>
-          <p:nvPr/>
-        </p:nvSpPr>
-        <p:spPr>
-          <a:xfrm>
-            <a:off x="8229600" y="4754880"/>
-            <a:ext cx="731520" cy="274320"/>
-          </a:xfrm>
-          <a:prstGeom prst="rect">
-            <a:avLst/>
-          </a:prstGeom>
-          <a:noFill/>
-        </p:spPr>
-        <p:txBody>
-          <a:bodyPr wrap="none">
-            <a:spAutoFit/>
-          </a:bodyPr>
-          <a:lstStyle/>
-          <a:p>
-            <a:pPr algn="ctr">
-              <a:defRPr sz="1000">
-                <a:solidFill>
-                  <a:srgbClr val="64748B"/>
-                </a:solidFill>
-              </a:defRPr>
-            </a:pPr>
-            <a:r>
-              <a:t>3/9</a:t>
-            </a:r>
-          </a:p>
-        </p:txBody>
-      </p:sp>
     </p:spTree>
   </p:cSld>
   <p:clrMapOvr>
@@ -3329,7 +3224,7 @@
       <p:grpSpPr/>
       <p:pic>
         <p:nvPicPr>
-          <p:cNvPr id="2" name="Picture 1" descr="Screenshot_4.png"/>
+          <p:cNvPr id="2" name="Picture 1" descr="Slide_4.png"/>
           <p:cNvPicPr>
             <a:picLocks noChangeAspect="1"/>
           </p:cNvPicPr>
@@ -3343,49 +3238,14 @@
         </p:blipFill>
         <p:spPr>
           <a:xfrm>
-            <a:off x="228600" y="130302"/>
-            <a:ext cx="8686800" cy="4882896"/>
+            <a:off x="0" y="0"/>
+            <a:ext cx="9144000" cy="5143500"/>
           </a:xfrm>
           <a:prstGeom prst="rect">
             <a:avLst/>
           </a:prstGeom>
         </p:spPr>
       </p:pic>
-      <p:sp>
-        <p:nvSpPr>
-          <p:cNvPr id="3" name="TextBox 2"/>
-          <p:cNvSpPr txBox="1"/>
-          <p:nvPr/>
-        </p:nvSpPr>
-        <p:spPr>
-          <a:xfrm>
-            <a:off x="8229600" y="4754880"/>
-            <a:ext cx="731520" cy="274320"/>
-          </a:xfrm>
-          <a:prstGeom prst="rect">
-            <a:avLst/>
-          </a:prstGeom>
-          <a:noFill/>
-        </p:spPr>
-        <p:txBody>
-          <a:bodyPr wrap="none">
-            <a:spAutoFit/>
-          </a:bodyPr>
-          <a:lstStyle/>
-          <a:p>
-            <a:pPr algn="ctr">
-              <a:defRPr sz="1000">
-                <a:solidFill>
-                  <a:srgbClr val="64748B"/>
-                </a:solidFill>
-              </a:defRPr>
-            </a:pPr>
-            <a:r>
-              <a:t>4/9</a:t>
-            </a:r>
-          </a:p>
-        </p:txBody>
-      </p:sp>
     </p:spTree>
   </p:cSld>
   <p:clrMapOvr>
@@ -3406,7 +3266,7 @@
       <p:grpSpPr/>
       <p:pic>
         <p:nvPicPr>
-          <p:cNvPr id="2" name="Picture 1" descr="Screenshot_5.png"/>
+          <p:cNvPr id="2" name="Picture 1" descr="Slide_5.png"/>
           <p:cNvPicPr>
             <a:picLocks noChangeAspect="1"/>
           </p:cNvPicPr>
@@ -3420,49 +3280,14 @@
         </p:blipFill>
         <p:spPr>
           <a:xfrm>
-            <a:off x="228600" y="130302"/>
-            <a:ext cx="8686800" cy="4882896"/>
+            <a:off x="0" y="0"/>
+            <a:ext cx="9144000" cy="5143500"/>
           </a:xfrm>
           <a:prstGeom prst="rect">
             <a:avLst/>
           </a:prstGeom>
         </p:spPr>
       </p:pic>
-      <p:sp>
-        <p:nvSpPr>
-          <p:cNvPr id="3" name="TextBox 2"/>
-          <p:cNvSpPr txBox="1"/>
-          <p:nvPr/>
-        </p:nvSpPr>
-        <p:spPr>
-          <a:xfrm>
-            <a:off x="8229600" y="4754880"/>
-            <a:ext cx="731520" cy="274320"/>
-          </a:xfrm>
-          <a:prstGeom prst="rect">
-            <a:avLst/>
-          </a:prstGeom>
-          <a:noFill/>
-        </p:spPr>
-        <p:txBody>
-          <a:bodyPr wrap="none">
-            <a:spAutoFit/>
-          </a:bodyPr>
-          <a:lstStyle/>
-          <a:p>
-            <a:pPr algn="ctr">
-              <a:defRPr sz="1000">
-                <a:solidFill>
-                  <a:srgbClr val="64748B"/>
-                </a:solidFill>
-              </a:defRPr>
-            </a:pPr>
-            <a:r>
-              <a:t>5/9</a:t>
-            </a:r>
-          </a:p>
-        </p:txBody>
-      </p:sp>
     </p:spTree>
   </p:cSld>
   <p:clrMapOvr>
@@ -3483,7 +3308,7 @@
       <p:grpSpPr/>
       <p:pic>
         <p:nvPicPr>
-          <p:cNvPr id="2" name="Picture 1" descr="Screenshot_6.png"/>
+          <p:cNvPr id="2" name="Picture 1" descr="Slide_6.png"/>
           <p:cNvPicPr>
             <a:picLocks noChangeAspect="1"/>
           </p:cNvPicPr>
@@ -3497,49 +3322,14 @@
         </p:blipFill>
         <p:spPr>
           <a:xfrm>
-            <a:off x="228600" y="130302"/>
-            <a:ext cx="8686800" cy="4882896"/>
+            <a:off x="0" y="0"/>
+            <a:ext cx="9144000" cy="5143500"/>
           </a:xfrm>
           <a:prstGeom prst="rect">
             <a:avLst/>
           </a:prstGeom>
         </p:spPr>
       </p:pic>
-      <p:sp>
-        <p:nvSpPr>
-          <p:cNvPr id="3" name="TextBox 2"/>
-          <p:cNvSpPr txBox="1"/>
-          <p:nvPr/>
-        </p:nvSpPr>
-        <p:spPr>
-          <a:xfrm>
-            <a:off x="8229600" y="4754880"/>
-            <a:ext cx="731520" cy="274320"/>
-          </a:xfrm>
-          <a:prstGeom prst="rect">
-            <a:avLst/>
-          </a:prstGeom>
-          <a:noFill/>
-        </p:spPr>
-        <p:txBody>
-          <a:bodyPr wrap="none">
-            <a:spAutoFit/>
-          </a:bodyPr>
-          <a:lstStyle/>
-          <a:p>
-            <a:pPr algn="ctr">
-              <a:defRPr sz="1000">
-                <a:solidFill>
-                  <a:srgbClr val="64748B"/>
-                </a:solidFill>
-              </a:defRPr>
-            </a:pPr>
-            <a:r>
-              <a:t>6/9</a:t>
-            </a:r>
-          </a:p>
-        </p:txBody>
-      </p:sp>
     </p:spTree>
   </p:cSld>
   <p:clrMapOvr>
@@ -3560,7 +3350,7 @@
       <p:grpSpPr/>
       <p:pic>
         <p:nvPicPr>
-          <p:cNvPr id="2" name="Picture 1" descr="Screenshot_7.png"/>
+          <p:cNvPr id="2" name="Picture 1" descr="Slide_7.png"/>
           <p:cNvPicPr>
             <a:picLocks noChangeAspect="1"/>
           </p:cNvPicPr>
@@ -3574,49 +3364,14 @@
         </p:blipFill>
         <p:spPr>
           <a:xfrm>
-            <a:off x="228600" y="130302"/>
-            <a:ext cx="8686800" cy="4882896"/>
+            <a:off x="0" y="0"/>
+            <a:ext cx="9144000" cy="5143500"/>
           </a:xfrm>
           <a:prstGeom prst="rect">
             <a:avLst/>
           </a:prstGeom>
         </p:spPr>
       </p:pic>
-      <p:sp>
-        <p:nvSpPr>
-          <p:cNvPr id="3" name="TextBox 2"/>
-          <p:cNvSpPr txBox="1"/>
-          <p:nvPr/>
-        </p:nvSpPr>
-        <p:spPr>
-          <a:xfrm>
-            <a:off x="8229600" y="4754880"/>
-            <a:ext cx="731520" cy="274320"/>
-          </a:xfrm>
-          <a:prstGeom prst="rect">
-            <a:avLst/>
-          </a:prstGeom>
-          <a:noFill/>
-        </p:spPr>
-        <p:txBody>
-          <a:bodyPr wrap="none">
-            <a:spAutoFit/>
-          </a:bodyPr>
-          <a:lstStyle/>
-          <a:p>
-            <a:pPr algn="ctr">
-              <a:defRPr sz="1000">
-                <a:solidFill>
-                  <a:srgbClr val="64748B"/>
-                </a:solidFill>
-              </a:defRPr>
-            </a:pPr>
-            <a:r>
-              <a:t>7/9</a:t>
-            </a:r>
-          </a:p>
-        </p:txBody>
-      </p:sp>
     </p:spTree>
   </p:cSld>
   <p:clrMapOvr>
@@ -3637,7 +3392,7 @@
       <p:grpSpPr/>
       <p:pic>
         <p:nvPicPr>
-          <p:cNvPr id="2" name="Picture 1" descr="Screenshot_8.png"/>
+          <p:cNvPr id="2" name="Picture 1" descr="Slide_8.png"/>
           <p:cNvPicPr>
             <a:picLocks noChangeAspect="1"/>
           </p:cNvPicPr>
@@ -3651,49 +3406,14 @@
         </p:blipFill>
         <p:spPr>
           <a:xfrm>
-            <a:off x="228600" y="130302"/>
-            <a:ext cx="8686800" cy="4882896"/>
+            <a:off x="0" y="0"/>
+            <a:ext cx="9144000" cy="5143500"/>
           </a:xfrm>
           <a:prstGeom prst="rect">
             <a:avLst/>
           </a:prstGeom>
         </p:spPr>
       </p:pic>
-      <p:sp>
-        <p:nvSpPr>
-          <p:cNvPr id="3" name="TextBox 2"/>
-          <p:cNvSpPr txBox="1"/>
-          <p:nvPr/>
-        </p:nvSpPr>
-        <p:spPr>
-          <a:xfrm>
-            <a:off x="8229600" y="4754880"/>
-            <a:ext cx="731520" cy="274320"/>
-          </a:xfrm>
-          <a:prstGeom prst="rect">
-            <a:avLst/>
-          </a:prstGeom>
-          <a:noFill/>
-        </p:spPr>
-        <p:txBody>
-          <a:bodyPr wrap="none">
-            <a:spAutoFit/>
-          </a:bodyPr>
-          <a:lstStyle/>
-          <a:p>
-            <a:pPr algn="ctr">
-              <a:defRPr sz="1000">
-                <a:solidFill>
-                  <a:srgbClr val="64748B"/>
-                </a:solidFill>
-              </a:defRPr>
-            </a:pPr>
-            <a:r>
-              <a:t>8/9</a:t>
-            </a:r>
-          </a:p>
-        </p:txBody>
-      </p:sp>
     </p:spTree>
   </p:cSld>
   <p:clrMapOvr>
@@ -3714,7 +3434,7 @@
       <p:grpSpPr/>
       <p:pic>
         <p:nvPicPr>
-          <p:cNvPr id="2" name="Picture 1" descr="Screenshot_9.png"/>
+          <p:cNvPr id="2" name="Picture 1" descr="Slide_9.png"/>
           <p:cNvPicPr>
             <a:picLocks noChangeAspect="1"/>
           </p:cNvPicPr>
@@ -3728,49 +3448,14 @@
         </p:blipFill>
         <p:spPr>
           <a:xfrm>
-            <a:off x="228600" y="130302"/>
-            <a:ext cx="8686800" cy="4882896"/>
+            <a:off x="0" y="0"/>
+            <a:ext cx="9144000" cy="5143500"/>
           </a:xfrm>
           <a:prstGeom prst="rect">
             <a:avLst/>
           </a:prstGeom>
         </p:spPr>
       </p:pic>
-      <p:sp>
-        <p:nvSpPr>
-          <p:cNvPr id="3" name="TextBox 2"/>
-          <p:cNvSpPr txBox="1"/>
-          <p:nvPr/>
-        </p:nvSpPr>
-        <p:spPr>
-          <a:xfrm>
-            <a:off x="8229600" y="4754880"/>
-            <a:ext cx="731520" cy="274320"/>
-          </a:xfrm>
-          <a:prstGeom prst="rect">
-            <a:avLst/>
-          </a:prstGeom>
-          <a:noFill/>
-        </p:spPr>
-        <p:txBody>
-          <a:bodyPr wrap="none">
-            <a:spAutoFit/>
-          </a:bodyPr>
-          <a:lstStyle/>
-          <a:p>
-            <a:pPr algn="ctr">
-              <a:defRPr sz="1000">
-                <a:solidFill>
-                  <a:srgbClr val="64748B"/>
-                </a:solidFill>
-              </a:defRPr>
-            </a:pPr>
-            <a:r>
-              <a:t>9/9</a:t>
-            </a:r>
-          </a:p>
-        </p:txBody>
-      </p:sp>
     </p:spTree>
   </p:cSld>
   <p:clrMapOvr>

</xml_diff>